<commit_message>
Stage 9: wrap-up - schema 1.1 API contract, README/technical docs/video script updated, PS_COMPLIANCE.md gap analysis, ACCURACY_ADDENDUM.md for the new models, regenerated deck/diagram/sample reports/screenshots/test report, FINAL_STATUS.md for the innovations branch
Co-Authored-By: Claude Sonnet 5 <noreply@anthropic.com>
</commit_message>
<xml_diff>
--- a/docs/IPsec_VPN_Analyzer_Deck.pptx
+++ b/docs/IPsec_VPN_Analyzer_Deck.pptx
@@ -17,6 +17,8 @@
     <p:sldId id="265" r:id="rId17"/>
     <p:sldId id="266" r:id="rId18"/>
     <p:sldId id="267" r:id="rId19"/>
+    <p:sldId id="268" r:id="rId20"/>
+    <p:sldId id="269" r:id="rId21"/>
   </p:sldIdLst>
   <p:sldSz cx="12191695" cy="6858000" type="screen4x3"/>
   <p:notesSz cx="6858000" cy="9144000"/>
@@ -583,7 +585,7 @@
           <a:lstStyle/>
           <a:p>
             <a:r>
-              <a:t>One click generates an executive summary or a technical report as HTML or PDF (Jinja2 to HTML to PDF with xhtml2pdf, no system dependencies).</a:t>
+              <a:t>Calibration can only soften confidence (temperature floored at 1). Open-set test: each traffic class was held out entirely and shown as unknown traffic. The defence table is a simulation: padding and dummy traffic fool a naive attacker, but an attacker who retrains is back to about 100 percent on this data.</a:t>
             </a:r>
           </a:p>
         </p:txBody>
@@ -653,7 +655,7 @@
           <a:lstStyle/>
           <a:p>
             <a:r>
-              <a:t>Everything runs locally and in Docker; deployment configs are provided. Deploying needs the team's own Vercel and Render logins, and we say so.</a:t>
+              <a:t>Live demo: upload a capture, read the gauge, threat matrix, traffic chart and timeline. The yellow badges show which values came from the file name.</a:t>
             </a:r>
           </a:p>
         </p:txBody>
@@ -723,6 +725,146 @@
           <a:lstStyle/>
           <a:p>
             <a:r>
+              <a:t>One click generates an executive summary or a technical report as HTML or PDF (Jinja2 to HTML to PDF with xhtml2pdf, no system dependencies).</a:t>
+            </a:r>
+          </a:p>
+        </p:txBody>
+      </p:sp>
+      <p:sp>
+        <p:nvSpPr>
+          <p:cNvPr id="4" name="Slide Number Placeholder 3"/>
+          <p:cNvSpPr>
+            <a:spLocks noGrp="1"/>
+          </p:cNvSpPr>
+          <p:nvPr>
+            <p:ph type="sldNum" idx="5" sz="quarter"/>
+          </p:nvPr>
+        </p:nvSpPr>
+        <p:spPr/>
+      </p:sp>
+    </p:spTree>
+  </p:cSld>
+  <p:clrMapOvr>
+    <a:masterClrMapping/>
+  </p:clrMapOvr>
+</p:notes>
+</file>
+
+<file path=ppt/notesSlides/notesSlide13.xml><?xml version="1.0" encoding="utf-8"?>
+<p:notes xmlns:a="http://schemas.openxmlformats.org/drawingml/2006/main" xmlns:p="http://schemas.openxmlformats.org/presentationml/2006/main" xmlns:r="http://schemas.openxmlformats.org/officeDocument/2006/relationships">
+  <p:cSld>
+    <p:spTree>
+      <p:nvGrpSpPr>
+        <p:cNvPr id="1" name=""/>
+        <p:cNvGrpSpPr/>
+        <p:nvPr/>
+      </p:nvGrpSpPr>
+      <p:grpSpPr>
+        <a:xfrm>
+          <a:off x="0" y="0"/>
+          <a:ext cx="0" cy="0"/>
+          <a:chOff x="0" y="0"/>
+          <a:chExt cx="0" cy="0"/>
+        </a:xfrm>
+      </p:grpSpPr>
+      <p:sp>
+        <p:nvSpPr>
+          <p:cNvPr id="2" name="Slide Image Placeholder 1"/>
+          <p:cNvSpPr>
+            <a:spLocks noGrp="1"/>
+          </p:cNvSpPr>
+          <p:nvPr>
+            <p:ph type="sldImg" idx="2"/>
+          </p:nvPr>
+        </p:nvSpPr>
+        <p:spPr/>
+      </p:sp>
+      <p:sp>
+        <p:nvSpPr>
+          <p:cNvPr id="3" name="Notes Placeholder 2"/>
+          <p:cNvSpPr>
+            <a:spLocks noGrp="1"/>
+          </p:cNvSpPr>
+          <p:nvPr>
+            <p:ph type="body" idx="3" sz="quarter"/>
+          </p:nvPr>
+        </p:nvSpPr>
+        <p:spPr/>
+        <p:txBody>
+          <a:bodyPr/>
+          <a:lstStyle/>
+          <a:p>
+            <a:r>
+              <a:t>Everything runs locally and in Docker; deployment configs are provided. Deploying needs the team's own Vercel and Render logins, and we say so.</a:t>
+            </a:r>
+          </a:p>
+        </p:txBody>
+      </p:sp>
+      <p:sp>
+        <p:nvSpPr>
+          <p:cNvPr id="4" name="Slide Number Placeholder 3"/>
+          <p:cNvSpPr>
+            <a:spLocks noGrp="1"/>
+          </p:cNvSpPr>
+          <p:nvPr>
+            <p:ph type="sldNum" idx="5" sz="quarter"/>
+          </p:nvPr>
+        </p:nvSpPr>
+        <p:spPr/>
+      </p:sp>
+    </p:spTree>
+  </p:cSld>
+  <p:clrMapOvr>
+    <a:masterClrMapping/>
+  </p:clrMapOvr>
+</p:notes>
+</file>
+
+<file path=ppt/notesSlides/notesSlide14.xml><?xml version="1.0" encoding="utf-8"?>
+<p:notes xmlns:a="http://schemas.openxmlformats.org/drawingml/2006/main" xmlns:p="http://schemas.openxmlformats.org/presentationml/2006/main" xmlns:r="http://schemas.openxmlformats.org/officeDocument/2006/relationships">
+  <p:cSld>
+    <p:spTree>
+      <p:nvGrpSpPr>
+        <p:cNvPr id="1" name=""/>
+        <p:cNvGrpSpPr/>
+        <p:nvPr/>
+      </p:nvGrpSpPr>
+      <p:grpSpPr>
+        <a:xfrm>
+          <a:off x="0" y="0"/>
+          <a:ext cx="0" cy="0"/>
+          <a:chOff x="0" y="0"/>
+          <a:chExt cx="0" cy="0"/>
+        </a:xfrm>
+      </p:grpSpPr>
+      <p:sp>
+        <p:nvSpPr>
+          <p:cNvPr id="2" name="Slide Image Placeholder 1"/>
+          <p:cNvSpPr>
+            <a:spLocks noGrp="1"/>
+          </p:cNvSpPr>
+          <p:nvPr>
+            <p:ph type="sldImg" idx="2"/>
+          </p:nvPr>
+        </p:nvSpPr>
+        <p:spPr/>
+      </p:sp>
+      <p:sp>
+        <p:nvSpPr>
+          <p:cNvPr id="3" name="Notes Placeholder 2"/>
+          <p:cNvSpPr>
+            <a:spLocks noGrp="1"/>
+          </p:cNvSpPr>
+          <p:nvPr>
+            <p:ph type="body" idx="3" sz="quarter"/>
+          </p:nvPr>
+        </p:nvSpPr>
+        <p:spPr/>
+        <p:txBody>
+          <a:bodyPr/>
+          <a:lstStyle/>
+          <a:p>
+            <a:r>
               <a:t>Be upfront: this is a lab dataset. The next milestone is re-running the fixed testbed.</a:t>
             </a:r>
           </a:p>
@@ -1003,7 +1145,7 @@
           <a:lstStyle/>
           <a:p>
             <a:r>
-              <a:t>The parser walks the IKE_SA_INIT exchange by hand from RFC 7296 and validates every header. Values that are not visible stay unknown and are excluded from the score - they are never counted as weak.</a:t>
+              <a:t>The parser walks the IKE_SA_INIT exchange by hand from RFC 7296 and validates every header. Values that are not visible stay unknown: excluded from the base score (never counted as weak) but they lower the completeness percentage and therefore the cap.</a:t>
             </a:r>
           </a:p>
         </p:txBody>
@@ -1283,7 +1425,7 @@
           <a:lstStyle/>
           <a:p>
             <a:r>
-              <a:t>Live demo: upload a capture, read the gauge, threat matrix, traffic chart and timeline. The yellow badges show which values came from the file name.</a:t>
+              <a:t>No file names, no keys. The ESP length modulo 16 separates CBC (one residue) from GCM (several). The rule abstains on constant-size streams such as ICMP instead of guessing. Say clearly what is not observable: AES-128 vs 256, PFS, authentication method, lifetime unless a rekey is seen.</a:t>
             </a:r>
           </a:p>
         </p:txBody>
@@ -4528,35 +4670,603 @@
               </a:defRPr>
             </a:pPr>
             <a:r>
-              <a:t>Real reports, generated on demand</a:t>
-            </a:r>
-          </a:p>
-        </p:txBody>
-      </p:sp>
-      <p:pic>
-        <p:nvPicPr>
-          <p:cNvPr id="4" name="Picture 3" descr="report-executive-p1.png"/>
-          <p:cNvPicPr>
-            <a:picLocks noChangeAspect="1"/>
-          </p:cNvPicPr>
+              <a:t>New: honest confidence, and a defence what-if</a:t>
+            </a:r>
+          </a:p>
+        </p:txBody>
+      </p:sp>
+      <p:graphicFrame>
+        <p:nvGraphicFramePr>
+          <p:cNvPr id="4" name="Table 3"/>
+          <p:cNvGraphicFramePr>
+            <a:graphicFrameLocks noGrp="1"/>
+          </p:cNvGraphicFramePr>
           <p:nvPr/>
-        </p:nvPicPr>
-        <p:blipFill>
-          <a:blip r:embed="rId3"/>
-          <a:stretch>
-            <a:fillRect/>
-          </a:stretch>
-        </p:blipFill>
-        <p:spPr>
-          <a:xfrm>
-            <a:off x="986443" y="1188720"/>
-            <a:ext cx="3879272" cy="5486400"/>
-          </a:xfrm>
-          <a:prstGeom prst="rect">
-            <a:avLst/>
-          </a:prstGeom>
-        </p:spPr>
-      </p:pic>
+        </p:nvGraphicFramePr>
+        <p:xfrm>
+          <a:off x="457200" y="1371600"/>
+          <a:ext cx="7223760" cy="2304288"/>
+        </p:xfrm>
+        <a:graphic>
+          <a:graphicData uri="http://schemas.openxmlformats.org/drawingml/2006/table">
+            <a:tbl>
+              <a:tblPr firstRow="1" bandRow="1">
+                <a:tableStyleId>{5C22544A-7EE6-4342-B048-85BDC9FD1C3A}</a:tableStyleId>
+              </a:tblPr>
+              <a:tblGrid>
+                <a:gridCol w="2926080"/>
+                <a:gridCol w="1463040"/>
+                <a:gridCol w="1280160"/>
+                <a:gridCol w="1554480"/>
+              </a:tblGrid>
+              <a:tr h="384048">
+                <a:tc>
+                  <a:txBody>
+                    <a:bodyPr/>
+                    <a:lstStyle/>
+                    <a:p>
+                      <a:pPr>
+                        <a:defRPr sz="1300" b="1">
+                          <a:solidFill>
+                            <a:srgbClr val="FFFFFF"/>
+                          </a:solidFill>
+                        </a:defRPr>
+                      </a:pPr>
+                      <a:r>
+                        <a:t>Defence (simulated)</a:t>
+                      </a:r>
+                    </a:p>
+                  </a:txBody>
+                  <a:tcPr>
+                    <a:solidFill>
+                      <a:srgbClr val="2B7BB9"/>
+                    </a:solidFill>
+                  </a:tcPr>
+                </a:tc>
+                <a:tc>
+                  <a:txBody>
+                    <a:bodyPr/>
+                    <a:lstStyle/>
+                    <a:p>
+                      <a:pPr>
+                        <a:defRPr sz="1300" b="1">
+                          <a:solidFill>
+                            <a:srgbClr val="FFFFFF"/>
+                          </a:solidFill>
+                        </a:defRPr>
+                      </a:pPr>
+                      <a:r>
+                        <a:t>Naive attacker</a:t>
+                      </a:r>
+                    </a:p>
+                  </a:txBody>
+                  <a:tcPr>
+                    <a:solidFill>
+                      <a:srgbClr val="2B7BB9"/>
+                    </a:solidFill>
+                  </a:tcPr>
+                </a:tc>
+                <a:tc>
+                  <a:txBody>
+                    <a:bodyPr/>
+                    <a:lstStyle/>
+                    <a:p>
+                      <a:pPr>
+                        <a:defRPr sz="1300" b="1">
+                          <a:solidFill>
+                            <a:srgbClr val="FFFFFF"/>
+                          </a:solidFill>
+                        </a:defRPr>
+                      </a:pPr>
+                      <a:r>
+                        <a:t>Adaptive</a:t>
+                      </a:r>
+                    </a:p>
+                  </a:txBody>
+                  <a:tcPr>
+                    <a:solidFill>
+                      <a:srgbClr val="2B7BB9"/>
+                    </a:solidFill>
+                  </a:tcPr>
+                </a:tc>
+                <a:tc>
+                  <a:txBody>
+                    <a:bodyPr/>
+                    <a:lstStyle/>
+                    <a:p>
+                      <a:pPr>
+                        <a:defRPr sz="1300" b="1">
+                          <a:solidFill>
+                            <a:srgbClr val="FFFFFF"/>
+                          </a:solidFill>
+                        </a:defRPr>
+                      </a:pPr>
+                      <a:r>
+                        <a:t>Extra bandwidth</a:t>
+                      </a:r>
+                    </a:p>
+                  </a:txBody>
+                  <a:tcPr>
+                    <a:solidFill>
+                      <a:srgbClr val="2B7BB9"/>
+                    </a:solidFill>
+                  </a:tcPr>
+                </a:tc>
+              </a:tr>
+              <a:tr h="384048">
+                <a:tc>
+                  <a:txBody>
+                    <a:bodyPr/>
+                    <a:lstStyle/>
+                    <a:p>
+                      <a:pPr>
+                        <a:defRPr sz="1300" b="0">
+                          <a:solidFill>
+                            <a:srgbClr val="1D2433"/>
+                          </a:solidFill>
+                        </a:defRPr>
+                      </a:pPr>
+                      <a:r>
+                        <a:t>Pad packets to size buckets</a:t>
+                      </a:r>
+                    </a:p>
+                  </a:txBody>
+                  <a:tcPr>
+                    <a:solidFill>
+                      <a:srgbClr val="EEF1F7"/>
+                    </a:solidFill>
+                  </a:tcPr>
+                </a:tc>
+                <a:tc>
+                  <a:txBody>
+                    <a:bodyPr/>
+                    <a:lstStyle/>
+                    <a:p>
+                      <a:pPr>
+                        <a:defRPr sz="1300" b="0">
+                          <a:solidFill>
+                            <a:srgbClr val="1D2433"/>
+                          </a:solidFill>
+                        </a:defRPr>
+                      </a:pPr>
+                      <a:r>
+                        <a:t>100 %</a:t>
+                      </a:r>
+                    </a:p>
+                  </a:txBody>
+                  <a:tcPr>
+                    <a:solidFill>
+                      <a:srgbClr val="EEF1F7"/>
+                    </a:solidFill>
+                  </a:tcPr>
+                </a:tc>
+                <a:tc>
+                  <a:txBody>
+                    <a:bodyPr/>
+                    <a:lstStyle/>
+                    <a:p>
+                      <a:pPr>
+                        <a:defRPr sz="1300" b="0">
+                          <a:solidFill>
+                            <a:srgbClr val="1D2433"/>
+                          </a:solidFill>
+                        </a:defRPr>
+                      </a:pPr>
+                      <a:r>
+                        <a:t>100 %</a:t>
+                      </a:r>
+                    </a:p>
+                  </a:txBody>
+                  <a:tcPr>
+                    <a:solidFill>
+                      <a:srgbClr val="EEF1F7"/>
+                    </a:solidFill>
+                  </a:tcPr>
+                </a:tc>
+                <a:tc>
+                  <a:txBody>
+                    <a:bodyPr/>
+                    <a:lstStyle/>
+                    <a:p>
+                      <a:pPr>
+                        <a:defRPr sz="1300" b="0">
+                          <a:solidFill>
+                            <a:srgbClr val="1D2433"/>
+                          </a:solidFill>
+                        </a:defRPr>
+                      </a:pPr>
+                      <a:r>
+                        <a:t>+10 %</a:t>
+                      </a:r>
+                    </a:p>
+                  </a:txBody>
+                  <a:tcPr>
+                    <a:solidFill>
+                      <a:srgbClr val="EEF1F7"/>
+                    </a:solidFill>
+                  </a:tcPr>
+                </a:tc>
+              </a:tr>
+              <a:tr h="384048">
+                <a:tc>
+                  <a:txBody>
+                    <a:bodyPr/>
+                    <a:lstStyle/>
+                    <a:p>
+                      <a:pPr>
+                        <a:defRPr sz="1300" b="0">
+                          <a:solidFill>
+                            <a:srgbClr val="1D2433"/>
+                          </a:solidFill>
+                        </a:defRPr>
+                      </a:pPr>
+                      <a:r>
+                        <a:t>Pad every packet to full size</a:t>
+                      </a:r>
+                    </a:p>
+                  </a:txBody>
+                  <a:tcPr>
+                    <a:solidFill>
+                      <a:srgbClr val="FFFFFF"/>
+                    </a:solidFill>
+                  </a:tcPr>
+                </a:tc>
+                <a:tc>
+                  <a:txBody>
+                    <a:bodyPr/>
+                    <a:lstStyle/>
+                    <a:p>
+                      <a:pPr>
+                        <a:defRPr sz="1300" b="0">
+                          <a:solidFill>
+                            <a:srgbClr val="1D2433"/>
+                          </a:solidFill>
+                        </a:defRPr>
+                      </a:pPr>
+                      <a:r>
+                        <a:t>42.8 %</a:t>
+                      </a:r>
+                    </a:p>
+                  </a:txBody>
+                  <a:tcPr>
+                    <a:solidFill>
+                      <a:srgbClr val="FFFFFF"/>
+                    </a:solidFill>
+                  </a:tcPr>
+                </a:tc>
+                <a:tc>
+                  <a:txBody>
+                    <a:bodyPr/>
+                    <a:lstStyle/>
+                    <a:p>
+                      <a:pPr>
+                        <a:defRPr sz="1300" b="0">
+                          <a:solidFill>
+                            <a:srgbClr val="1D2433"/>
+                          </a:solidFill>
+                        </a:defRPr>
+                      </a:pPr>
+                      <a:r>
+                        <a:t>100 %</a:t>
+                      </a:r>
+                    </a:p>
+                  </a:txBody>
+                  <a:tcPr>
+                    <a:solidFill>
+                      <a:srgbClr val="FFFFFF"/>
+                    </a:solidFill>
+                  </a:tcPr>
+                </a:tc>
+                <a:tc>
+                  <a:txBody>
+                    <a:bodyPr/>
+                    <a:lstStyle/>
+                    <a:p>
+                      <a:pPr>
+                        <a:defRPr sz="1300" b="0">
+                          <a:solidFill>
+                            <a:srgbClr val="1D2433"/>
+                          </a:solidFill>
+                        </a:defRPr>
+                      </a:pPr>
+                      <a:r>
+                        <a:t>+223 %</a:t>
+                      </a:r>
+                    </a:p>
+                  </a:txBody>
+                  <a:tcPr>
+                    <a:solidFill>
+                      <a:srgbClr val="FFFFFF"/>
+                    </a:solidFill>
+                  </a:tcPr>
+                </a:tc>
+              </a:tr>
+              <a:tr h="384048">
+                <a:tc>
+                  <a:txBody>
+                    <a:bodyPr/>
+                    <a:lstStyle/>
+                    <a:p>
+                      <a:pPr>
+                        <a:defRPr sz="1300" b="0">
+                          <a:solidFill>
+                            <a:srgbClr val="1D2433"/>
+                          </a:solidFill>
+                        </a:defRPr>
+                      </a:pPr>
+                      <a:r>
+                        <a:t>Constant-rate dummy traffic</a:t>
+                      </a:r>
+                    </a:p>
+                  </a:txBody>
+                  <a:tcPr>
+                    <a:solidFill>
+                      <a:srgbClr val="EEF1F7"/>
+                    </a:solidFill>
+                  </a:tcPr>
+                </a:tc>
+                <a:tc>
+                  <a:txBody>
+                    <a:bodyPr/>
+                    <a:lstStyle/>
+                    <a:p>
+                      <a:pPr>
+                        <a:defRPr sz="1300" b="0">
+                          <a:solidFill>
+                            <a:srgbClr val="1D2433"/>
+                          </a:solidFill>
+                        </a:defRPr>
+                      </a:pPr>
+                      <a:r>
+                        <a:t>60 %</a:t>
+                      </a:r>
+                    </a:p>
+                  </a:txBody>
+                  <a:tcPr>
+                    <a:solidFill>
+                      <a:srgbClr val="EEF1F7"/>
+                    </a:solidFill>
+                  </a:tcPr>
+                </a:tc>
+                <a:tc>
+                  <a:txBody>
+                    <a:bodyPr/>
+                    <a:lstStyle/>
+                    <a:p>
+                      <a:pPr>
+                        <a:defRPr sz="1300" b="0">
+                          <a:solidFill>
+                            <a:srgbClr val="1D2433"/>
+                          </a:solidFill>
+                        </a:defRPr>
+                      </a:pPr>
+                      <a:r>
+                        <a:t>100 %</a:t>
+                      </a:r>
+                    </a:p>
+                  </a:txBody>
+                  <a:tcPr>
+                    <a:solidFill>
+                      <a:srgbClr val="EEF1F7"/>
+                    </a:solidFill>
+                  </a:tcPr>
+                </a:tc>
+                <a:tc>
+                  <a:txBody>
+                    <a:bodyPr/>
+                    <a:lstStyle/>
+                    <a:p>
+                      <a:pPr>
+                        <a:defRPr sz="1300" b="0">
+                          <a:solidFill>
+                            <a:srgbClr val="1D2433"/>
+                          </a:solidFill>
+                        </a:defRPr>
+                      </a:pPr>
+                      <a:r>
+                        <a:t>+72 %</a:t>
+                      </a:r>
+                    </a:p>
+                  </a:txBody>
+                  <a:tcPr>
+                    <a:solidFill>
+                      <a:srgbClr val="EEF1F7"/>
+                    </a:solidFill>
+                  </a:tcPr>
+                </a:tc>
+              </a:tr>
+              <a:tr h="384048">
+                <a:tc>
+                  <a:txBody>
+                    <a:bodyPr/>
+                    <a:lstStyle/>
+                    <a:p>
+                      <a:pPr>
+                        <a:defRPr sz="1300" b="0">
+                          <a:solidFill>
+                            <a:srgbClr val="1D2433"/>
+                          </a:solidFill>
+                        </a:defRPr>
+                      </a:pPr>
+                      <a:r>
+                        <a:t>Random delay (timing jitter)</a:t>
+                      </a:r>
+                    </a:p>
+                  </a:txBody>
+                  <a:tcPr>
+                    <a:solidFill>
+                      <a:srgbClr val="FFFFFF"/>
+                    </a:solidFill>
+                  </a:tcPr>
+                </a:tc>
+                <a:tc>
+                  <a:txBody>
+                    <a:bodyPr/>
+                    <a:lstStyle/>
+                    <a:p>
+                      <a:pPr>
+                        <a:defRPr sz="1300" b="0">
+                          <a:solidFill>
+                            <a:srgbClr val="1D2433"/>
+                          </a:solidFill>
+                        </a:defRPr>
+                      </a:pPr>
+                      <a:r>
+                        <a:t>99.4 %</a:t>
+                      </a:r>
+                    </a:p>
+                  </a:txBody>
+                  <a:tcPr>
+                    <a:solidFill>
+                      <a:srgbClr val="FFFFFF"/>
+                    </a:solidFill>
+                  </a:tcPr>
+                </a:tc>
+                <a:tc>
+                  <a:txBody>
+                    <a:bodyPr/>
+                    <a:lstStyle/>
+                    <a:p>
+                      <a:pPr>
+                        <a:defRPr sz="1300" b="0">
+                          <a:solidFill>
+                            <a:srgbClr val="1D2433"/>
+                          </a:solidFill>
+                        </a:defRPr>
+                      </a:pPr>
+                      <a:r>
+                        <a:t>100 %</a:t>
+                      </a:r>
+                    </a:p>
+                  </a:txBody>
+                  <a:tcPr>
+                    <a:solidFill>
+                      <a:srgbClr val="FFFFFF"/>
+                    </a:solidFill>
+                  </a:tcPr>
+                </a:tc>
+                <a:tc>
+                  <a:txBody>
+                    <a:bodyPr/>
+                    <a:lstStyle/>
+                    <a:p>
+                      <a:pPr>
+                        <a:defRPr sz="1300" b="0">
+                          <a:solidFill>
+                            <a:srgbClr val="1D2433"/>
+                          </a:solidFill>
+                        </a:defRPr>
+                      </a:pPr>
+                      <a:r>
+                        <a:t>+0 %</a:t>
+                      </a:r>
+                    </a:p>
+                  </a:txBody>
+                  <a:tcPr>
+                    <a:solidFill>
+                      <a:srgbClr val="FFFFFF"/>
+                    </a:solidFill>
+                  </a:tcPr>
+                </a:tc>
+              </a:tr>
+              <a:tr h="384048">
+                <a:tc>
+                  <a:txBody>
+                    <a:bodyPr/>
+                    <a:lstStyle/>
+                    <a:p>
+                      <a:pPr>
+                        <a:defRPr sz="1300" b="0">
+                          <a:solidFill>
+                            <a:srgbClr val="1D2433"/>
+                          </a:solidFill>
+                        </a:defRPr>
+                      </a:pPr>
+                      <a:r>
+                        <a:t>Combined</a:t>
+                      </a:r>
+                    </a:p>
+                  </a:txBody>
+                  <a:tcPr>
+                    <a:solidFill>
+                      <a:srgbClr val="EEF1F7"/>
+                    </a:solidFill>
+                  </a:tcPr>
+                </a:tc>
+                <a:tc>
+                  <a:txBody>
+                    <a:bodyPr/>
+                    <a:lstStyle/>
+                    <a:p>
+                      <a:pPr>
+                        <a:defRPr sz="1300" b="0">
+                          <a:solidFill>
+                            <a:srgbClr val="1D2433"/>
+                          </a:solidFill>
+                        </a:defRPr>
+                      </a:pPr>
+                      <a:r>
+                        <a:t>60 %</a:t>
+                      </a:r>
+                    </a:p>
+                  </a:txBody>
+                  <a:tcPr>
+                    <a:solidFill>
+                      <a:srgbClr val="EEF1F7"/>
+                    </a:solidFill>
+                  </a:tcPr>
+                </a:tc>
+                <a:tc>
+                  <a:txBody>
+                    <a:bodyPr/>
+                    <a:lstStyle/>
+                    <a:p>
+                      <a:pPr>
+                        <a:defRPr sz="1300" b="0">
+                          <a:solidFill>
+                            <a:srgbClr val="1D2433"/>
+                          </a:solidFill>
+                        </a:defRPr>
+                      </a:pPr>
+                      <a:r>
+                        <a:t>100 %</a:t>
+                      </a:r>
+                    </a:p>
+                  </a:txBody>
+                  <a:tcPr>
+                    <a:solidFill>
+                      <a:srgbClr val="EEF1F7"/>
+                    </a:solidFill>
+                  </a:tcPr>
+                </a:tc>
+                <a:tc>
+                  <a:txBody>
+                    <a:bodyPr/>
+                    <a:lstStyle/>
+                    <a:p>
+                      <a:pPr>
+                        <a:defRPr sz="1300" b="0">
+                          <a:solidFill>
+                            <a:srgbClr val="1D2433"/>
+                          </a:solidFill>
+                        </a:defRPr>
+                      </a:pPr>
+                      <a:r>
+                        <a:t>+119 %</a:t>
+                      </a:r>
+                    </a:p>
+                  </a:txBody>
+                  <a:tcPr>
+                    <a:solidFill>
+                      <a:srgbClr val="EEF1F7"/>
+                    </a:solidFill>
+                  </a:tcPr>
+                </a:tc>
+              </a:tr>
+            </a:tbl>
+          </a:graphicData>
+        </a:graphic>
+      </p:graphicFrame>
       <p:sp>
         <p:nvSpPr>
           <p:cNvPr id="5" name="TextBox 4"/>
@@ -4565,8 +5275,8 @@
         </p:nvSpPr>
         <p:spPr>
           <a:xfrm>
-            <a:off x="5669280" y="1554480"/>
-            <a:ext cx="6035040" cy="4572000"/>
+            <a:off x="7863840" y="1371600"/>
+            <a:ext cx="4023360" cy="4114800"/>
           </a:xfrm>
           <a:prstGeom prst="rect">
             <a:avLst/>
@@ -4585,20 +5295,20 @@
               </a:spcAft>
             </a:pPr>
             <a:r>
-              <a:rPr b="1" sz="1900">
+              <a:rPr b="1" sz="1500">
                 <a:solidFill>
                   <a:srgbClr val="1D2433"/>
                 </a:solidFill>
               </a:rPr>
-              <a:t>Executive summary: </a:t>
-            </a:r>
-            <a:r>
-              <a:rPr sz="1900">
+              <a:t>Unrecognised traffic: </a:t>
+            </a:r>
+            <a:r>
+              <a:rPr sz="1500">
                 <a:solidFill>
                   <a:srgbClr val="1D2433"/>
                 </a:solidFill>
               </a:rPr>
-              <a:t>risk box, plain-language settings table, rule-based recommendations, what the report cannot tell you</a:t>
+              <a:t>100 % of held-out-class captures rejected; 94.7 % of known accepted</a:t>
             </a:r>
           </a:p>
           <a:p>
@@ -4608,20 +5318,20 @@
               </a:spcAft>
             </a:pPr>
             <a:r>
-              <a:rPr b="1" sz="1900">
+              <a:rPr b="1" sz="1500">
                 <a:solidFill>
                   <a:srgbClr val="1D2433"/>
                 </a:solidFill>
               </a:rPr>
-              <a:t>Technical report: </a:t>
-            </a:r>
-            <a:r>
-              <a:rPr sz="1900">
+              <a:t>Lab limit: </a:t>
+            </a:r>
+            <a:r>
+              <a:rPr sz="1500">
                 <a:solidFill>
                   <a:srgbClr val="1D2433"/>
                 </a:solidFill>
               </a:rPr>
-              <a:t>score arithmetic, IKE parse facts, class probabilities, SHAP, timeline, anomalies, model validation</a:t>
+              <a:t>five very different classes; real unknowns will be harder</a:t>
             </a:r>
           </a:p>
           <a:p>
@@ -4631,20 +5341,20 @@
               </a:spcAft>
             </a:pPr>
             <a:r>
-              <a:rPr b="1" sz="1900">
+              <a:rPr b="1" sz="1500">
                 <a:solidFill>
                   <a:srgbClr val="1D2433"/>
                 </a:solidFill>
               </a:rPr>
-              <a:t>Windows-safe: </a:t>
-            </a:r>
-            <a:r>
-              <a:rPr sz="1900">
+              <a:t>Defences: </a:t>
+            </a:r>
+            <a:r>
+              <a:rPr sz="1500">
                 <a:solidFill>
                   <a:srgbClr val="1D2433"/>
                 </a:solidFill>
               </a:rPr>
-              <a:t>pure-Python PDF engine: installs with pip, runs on hosting</a:t>
+              <a:t>no defence stopped an adaptive attacker here</a:t>
             </a:r>
           </a:p>
         </p:txBody>
@@ -4740,126 +5450,35 @@
               </a:defRPr>
             </a:pPr>
             <a:r>
-              <a:t>Quality and deployment</a:t>
-            </a:r>
-          </a:p>
-        </p:txBody>
-      </p:sp>
-      <p:sp>
-        <p:nvSpPr>
-          <p:cNvPr id="4" name="TextBox 3"/>
-          <p:cNvSpPr txBox="1"/>
+              <a:t>The dashboard</a:t>
+            </a:r>
+          </a:p>
+        </p:txBody>
+      </p:sp>
+      <p:pic>
+        <p:nvPicPr>
+          <p:cNvPr id="4" name="Picture 3" descr="dashboard-top.png"/>
+          <p:cNvPicPr>
+            <a:picLocks noChangeAspect="1"/>
+          </p:cNvPicPr>
           <p:nvPr/>
-        </p:nvSpPr>
+        </p:nvPicPr>
+        <p:blipFill>
+          <a:blip r:embed="rId3"/>
+          <a:stretch>
+            <a:fillRect/>
+          </a:stretch>
+        </p:blipFill>
         <p:spPr>
           <a:xfrm>
-            <a:off x="640080" y="1554480"/>
-            <a:ext cx="10972800" cy="4572000"/>
+            <a:off x="2704513" y="1188720"/>
+            <a:ext cx="6752492" cy="5486400"/>
           </a:xfrm>
           <a:prstGeom prst="rect">
             <a:avLst/>
           </a:prstGeom>
-          <a:noFill/>
         </p:spPr>
-        <p:txBody>
-          <a:bodyPr wrap="square">
-            <a:spAutoFit/>
-          </a:bodyPr>
-          <a:lstStyle/>
-          <a:p>
-            <a:pPr>
-              <a:spcAft>
-                <a:spcPts val="900"/>
-              </a:spcAft>
-            </a:pPr>
-            <a:r>
-              <a:rPr b="1" sz="2000">
-                <a:solidFill>
-                  <a:srgbClr val="1D2433"/>
-                </a:solidFill>
-              </a:rPr>
-              <a:t>Automated tests: </a:t>
-            </a:r>
-            <a:r>
-              <a:rPr sz="2000">
-                <a:solidFill>
-                  <a:srgbClr val="1D2433"/>
-                </a:solidFill>
-              </a:rPr>
-              <a:t>pytest suite (IKE parser on synthetic fixtures, scoring, ML, API, reports, testbed) + real-browser end-to-end check</a:t>
-            </a:r>
-          </a:p>
-          <a:p>
-            <a:pPr>
-              <a:spcAft>
-                <a:spcPts val="900"/>
-              </a:spcAft>
-            </a:pPr>
-            <a:r>
-              <a:rPr b="1" sz="2000">
-                <a:solidFill>
-                  <a:srgbClr val="1D2433"/>
-                </a:solidFill>
-              </a:rPr>
-              <a:t>One API contract: </a:t>
-            </a:r>
-            <a:r>
-              <a:rPr sz="2000">
-                <a:solidFill>
-                  <a:srgbClr val="1D2433"/>
-                </a:solidFill>
-              </a:rPr>
-              <a:t>score, risk, cipher, mode, DH group, PFS, breakdown, explanation, anomalies, timeline, confidence</a:t>
-            </a:r>
-          </a:p>
-          <a:p>
-            <a:pPr>
-              <a:spcAft>
-                <a:spcPts val="900"/>
-              </a:spcAft>
-            </a:pPr>
-            <a:r>
-              <a:rPr b="1" sz="2000">
-                <a:solidFill>
-                  <a:srgbClr val="1D2433"/>
-                </a:solidFill>
-              </a:rPr>
-              <a:t>Packaging: </a:t>
-            </a:r>
-            <a:r>
-              <a:rPr sz="2000">
-                <a:solidFill>
-                  <a:srgbClr val="1D2433"/>
-                </a:solidFill>
-              </a:rPr>
-              <a:t>Dockerfiles, docker-compose, Render / Railway / Vercel / Netlify configs, click-by-click DEPLOY.md</a:t>
-            </a:r>
-          </a:p>
-          <a:p>
-            <a:pPr>
-              <a:spcAft>
-                <a:spcPts val="900"/>
-              </a:spcAft>
-            </a:pPr>
-            <a:r>
-              <a:rPr b="1" sz="2000">
-                <a:solidFill>
-                  <a:srgbClr val="1D2433"/>
-                </a:solidFill>
-              </a:rPr>
-              <a:t>Measured: </a:t>
-            </a:r>
-            <a:r>
-              <a:rPr sz="2000">
-                <a:solidFill>
-                  <a:srgbClr val="1D2433"/>
-                </a:solidFill>
-              </a:rPr>
-              <a:t>~320 MB RAM for the API after an analysis plus a PDF report</a:t>
-            </a:r>
-          </a:p>
-        </p:txBody>
-      </p:sp>
+      </p:pic>
     </p:spTree>
   </p:cSld>
   <p:clrMapOvr>
@@ -4951,21 +5570,45 @@
               </a:defRPr>
             </a:pPr>
             <a:r>
-              <a:t>Limitations and next steps</a:t>
-            </a:r>
-          </a:p>
-        </p:txBody>
-      </p:sp>
-      <p:sp>
-        <p:nvSpPr>
-          <p:cNvPr id="4" name="TextBox 3"/>
+              <a:t>Real reports, generated on demand</a:t>
+            </a:r>
+          </a:p>
+        </p:txBody>
+      </p:sp>
+      <p:pic>
+        <p:nvPicPr>
+          <p:cNvPr id="4" name="Picture 3" descr="report-executive-p1.png"/>
+          <p:cNvPicPr>
+            <a:picLocks noChangeAspect="1"/>
+          </p:cNvPicPr>
+          <p:nvPr/>
+        </p:nvPicPr>
+        <p:blipFill>
+          <a:blip r:embed="rId3"/>
+          <a:stretch>
+            <a:fillRect/>
+          </a:stretch>
+        </p:blipFill>
+        <p:spPr>
+          <a:xfrm>
+            <a:off x="986443" y="1188720"/>
+            <a:ext cx="3879272" cy="5486400"/>
+          </a:xfrm>
+          <a:prstGeom prst="rect">
+            <a:avLst/>
+          </a:prstGeom>
+        </p:spPr>
+      </p:pic>
+      <p:sp>
+        <p:nvSpPr>
+          <p:cNvPr id="5" name="TextBox 4"/>
           <p:cNvSpPr txBox="1"/>
           <p:nvPr/>
         </p:nvSpPr>
         <p:spPr>
           <a:xfrm>
-            <a:off x="640080" y="1554480"/>
-            <a:ext cx="10972800" cy="4572000"/>
+            <a:off x="5669280" y="1554480"/>
+            <a:ext cx="6035040" cy="4572000"/>
           </a:xfrm>
           <a:prstGeom prst="rect">
             <a:avLst/>
@@ -4984,20 +5627,20 @@
               </a:spcAft>
             </a:pPr>
             <a:r>
-              <a:rPr b="1" sz="2100">
+              <a:rPr b="1" sz="1900">
                 <a:solidFill>
                   <a:srgbClr val="1D2433"/>
                 </a:solidFill>
               </a:rPr>
-              <a:t>Limits: </a:t>
-            </a:r>
-            <a:r>
-              <a:rPr sz="2100">
+              <a:t>Executive summary: </a:t>
+            </a:r>
+            <a:r>
+              <a:rPr sz="1900">
                 <a:solidFill>
                   <a:srgbClr val="1D2433"/>
                 </a:solidFill>
               </a:rPr>
-              <a:t>one capture per config and class; scripted traffic; short captures for file transfer, VoIP, video; SIP only for VoIP</a:t>
+              <a:t>risk box, plain-language settings table, rule-based recommendations, what the report cannot tell you</a:t>
             </a:r>
           </a:p>
           <a:p>
@@ -5007,20 +5650,20 @@
               </a:spcAft>
             </a:pPr>
             <a:r>
-              <a:rPr b="1" sz="2100">
+              <a:rPr b="1" sz="1900">
                 <a:solidFill>
                   <a:srgbClr val="1D2433"/>
                 </a:solidFill>
               </a:rPr>
-              <a:t>IKE parser: </a:t>
-            </a:r>
-            <a:r>
-              <a:rPr sz="2100">
+              <a:t>Technical report: </a:t>
+            </a:r>
+            <a:r>
+              <a:rPr sz="1900">
                 <a:solidFill>
                   <a:srgbClr val="1D2433"/>
                 </a:solidFill>
               </a:rPr>
-              <a:t>only tested on synthetic IKE_SA_INIT (none exists in the data yet)</a:t>
+              <a:t>score arithmetic, IKE parse facts, class probabilities, SHAP, timeline, anomalies, model validation</a:t>
             </a:r>
           </a:p>
           <a:p>
@@ -5030,43 +5673,20 @@
               </a:spcAft>
             </a:pPr>
             <a:r>
-              <a:rPr b="1" sz="2100">
+              <a:rPr b="1" sz="1900">
                 <a:solidFill>
                   <a:srgbClr val="1D2433"/>
                 </a:solidFill>
               </a:rPr>
-              <a:t>Next: </a:t>
-            </a:r>
-            <a:r>
-              <a:rPr sz="2100">
+              <a:t>Windows-safe: </a:t>
+            </a:r>
+            <a:r>
+              <a:rPr sz="1900">
                 <a:solidFill>
                   <a:srgbClr val="1D2433"/>
                 </a:solidFill>
               </a:rPr>
-              <a:t>re-run the fixed testbed (real handshakes, real PFS labels, 30 s captures, repeats)</a:t>
-            </a:r>
-          </a:p>
-          <a:p>
-            <a:pPr>
-              <a:spcAft>
-                <a:spcPts val="900"/>
-              </a:spcAft>
-            </a:pPr>
-            <a:r>
-              <a:rPr b="1" sz="2100">
-                <a:solidFill>
-                  <a:srgbClr val="1D2433"/>
-                </a:solidFill>
-              </a:rPr>
-              <a:t>Next: </a:t>
-            </a:r>
-            <a:r>
-              <a:rPr sz="2100">
-                <a:solidFill>
-                  <a:srgbClr val="1D2433"/>
-                </a:solidFill>
-              </a:rPr>
-              <a:t>non-scripted traffic, IKEv1, authentication and rate limiting for a public deployment</a:t>
+              <a:t>pure-Python PDF engine: installs with pip, runs on hosting</a:t>
             </a:r>
           </a:p>
         </p:txBody>
@@ -5079,7 +5699,7 @@
 </p:sld>
 </file>
 
-<file path=ppt/slides/slide2.xml><?xml version="1.0" encoding="utf-8"?>
+<file path=ppt/slides/slide13.xml><?xml version="1.0" encoding="utf-8"?>
 <p:sld xmlns:a="http://schemas.openxmlformats.org/drawingml/2006/main" xmlns:p="http://schemas.openxmlformats.org/presentationml/2006/main" xmlns:r="http://schemas.openxmlformats.org/officeDocument/2006/relationships">
   <p:cSld>
     <p:spTree>
@@ -5162,7 +5782,7 @@
               </a:defRPr>
             </a:pPr>
             <a:r>
-              <a:t>The problem: encrypted does not mean understood</a:t>
+              <a:t>Quality and deployment</a:t>
             </a:r>
           </a:p>
         </p:txBody>
@@ -5176,7 +5796,7 @@
         <p:spPr>
           <a:xfrm>
             <a:off x="640080" y="1554480"/>
-            <a:ext cx="10972800" cy="4389120"/>
+            <a:ext cx="10972800" cy="4572000"/>
           </a:xfrm>
           <a:prstGeom prst="rect">
             <a:avLst/>
@@ -5195,20 +5815,20 @@
               </a:spcAft>
             </a:pPr>
             <a:r>
-              <a:rPr b="1" sz="2200">
+              <a:rPr b="1" sz="2000">
                 <a:solidFill>
                   <a:srgbClr val="1D2433"/>
                 </a:solidFill>
               </a:rPr>
-              <a:t>Is the VPN configured well?: </a:t>
-            </a:r>
-            <a:r>
-              <a:rPr sz="2200">
+              <a:t>Automated tests: </a:t>
+            </a:r>
+            <a:r>
+              <a:rPr sz="2000">
                 <a:solidFill>
                   <a:srgbClr val="1D2433"/>
                 </a:solidFill>
               </a:rPr>
-              <a:t>Cipher, key exchange group, forward secrecy, tunnel vs transport mode.</a:t>
+              <a:t>243 pytest tests (synthetic IKE / ESP / IPv6 / AH fixtures, scoring, ML, API, replay, reports, testbed) + real-browser end-to-end check</a:t>
             </a:r>
           </a:p>
           <a:p>
@@ -5218,20 +5838,20 @@
               </a:spcAft>
             </a:pPr>
             <a:r>
-              <a:rPr b="1" sz="2200">
+              <a:rPr b="1" sz="2000">
                 <a:solidFill>
                   <a:srgbClr val="1D2433"/>
                 </a:solidFill>
               </a:rPr>
-              <a:t>What is inside the tunnel?: </a:t>
-            </a:r>
-            <a:r>
-              <a:rPr sz="2200">
+              <a:t>One API contract: </a:t>
+            </a:r>
+            <a:r>
+              <a:rPr sz="2000">
                 <a:solidFill>
                   <a:srgbClr val="1D2433"/>
                 </a:solidFill>
               </a:rPr>
-              <a:t>Web, video, voice, file transfer, ping - without decrypting.</a:t>
+              <a:t>schema 1.1: score + cap, findings with status, recommendations, fingerprint, sequence, defence simulation</a:t>
             </a:r>
           </a:p>
           <a:p>
@@ -5241,20 +5861,20 @@
               </a:spcAft>
             </a:pPr>
             <a:r>
-              <a:rPr b="1" sz="2200">
+              <a:rPr b="1" sz="2000">
                 <a:solidFill>
                   <a:srgbClr val="1D2433"/>
                 </a:solidFill>
               </a:rPr>
-              <a:t>Hard part: </a:t>
-            </a:r>
-            <a:r>
-              <a:rPr sz="2200">
+              <a:t>Packaging: </a:t>
+            </a:r>
+            <a:r>
+              <a:rPr sz="2000">
                 <a:solidFill>
                   <a:srgbClr val="1D2433"/>
                 </a:solidFill>
               </a:rPr>
-              <a:t>only the first IKE message (IKE_SA_INIT) is readable; everything after it is encrypted.</a:t>
+              <a:t>Dockerfiles, docker-compose, Render / Railway / Vercel / Netlify configs, click-by-click DEPLOY.md</a:t>
             </a:r>
           </a:p>
           <a:p>
@@ -5264,20 +5884,20 @@
               </a:spcAft>
             </a:pPr>
             <a:r>
-              <a:rPr b="1" sz="2200">
+              <a:rPr b="1" sz="2000">
                 <a:solidFill>
                   <a:srgbClr val="1D2433"/>
                 </a:solidFill>
               </a:rPr>
-              <a:t>Our stance: </a:t>
-            </a:r>
-            <a:r>
-              <a:rPr sz="2200">
+              <a:t>Measured: </a:t>
+            </a:r>
+            <a:r>
+              <a:rPr sz="2000">
                 <a:solidFill>
                   <a:srgbClr val="1D2433"/>
                 </a:solidFill>
               </a:rPr>
-              <a:t>never present a guess as a measurement - every value is tagged observed / declared / unknown.</a:t>
+              <a:t>~320 MB RAM for the API after an analysis plus a PDF report</a:t>
             </a:r>
           </a:p>
         </p:txBody>
@@ -5290,7 +5910,7 @@
 </p:sld>
 </file>
 
-<file path=ppt/slides/slide3.xml><?xml version="1.0" encoding="utf-8"?>
+<file path=ppt/slides/slide14.xml><?xml version="1.0" encoding="utf-8"?>
 <p:sld xmlns:a="http://schemas.openxmlformats.org/drawingml/2006/main" xmlns:p="http://schemas.openxmlformats.org/presentationml/2006/main" xmlns:r="http://schemas.openxmlformats.org/officeDocument/2006/relationships">
   <p:cSld>
     <p:spTree>
@@ -5373,7 +5993,241 @@
               </a:defRPr>
             </a:pPr>
             <a:r>
-              <a:t>What we built</a:t>
+              <a:t>Limitations and next steps</a:t>
+            </a:r>
+          </a:p>
+        </p:txBody>
+      </p:sp>
+      <p:sp>
+        <p:nvSpPr>
+          <p:cNvPr id="4" name="TextBox 3"/>
+          <p:cNvSpPr txBox="1"/>
+          <p:nvPr/>
+        </p:nvSpPr>
+        <p:spPr>
+          <a:xfrm>
+            <a:off x="640080" y="1554480"/>
+            <a:ext cx="10972800" cy="4572000"/>
+          </a:xfrm>
+          <a:prstGeom prst="rect">
+            <a:avLst/>
+          </a:prstGeom>
+          <a:noFill/>
+        </p:spPr>
+        <p:txBody>
+          <a:bodyPr wrap="square">
+            <a:spAutoFit/>
+          </a:bodyPr>
+          <a:lstStyle/>
+          <a:p>
+            <a:pPr>
+              <a:spcAft>
+                <a:spcPts val="900"/>
+              </a:spcAft>
+            </a:pPr>
+            <a:r>
+              <a:rPr b="1" sz="2100">
+                <a:solidFill>
+                  <a:srgbClr val="1D2433"/>
+                </a:solidFill>
+              </a:rPr>
+              <a:t>Limits: </a:t>
+            </a:r>
+            <a:r>
+              <a:rPr sz="2100">
+                <a:solidFill>
+                  <a:srgbClr val="1D2433"/>
+                </a:solidFill>
+              </a:rPr>
+              <a:t>one capture per config and class; scripted traffic; short captures for file transfer, VoIP, video; SIP only for VoIP</a:t>
+            </a:r>
+          </a:p>
+          <a:p>
+            <a:pPr>
+              <a:spcAft>
+                <a:spcPts val="900"/>
+              </a:spcAft>
+            </a:pPr>
+            <a:r>
+              <a:rPr b="1" sz="2100">
+                <a:solidFill>
+                  <a:srgbClr val="1D2433"/>
+                </a:solidFill>
+              </a:rPr>
+              <a:t>Synthetic only: </a:t>
+            </a:r>
+            <a:r>
+              <a:rPr sz="2100">
+                <a:solidFill>
+                  <a:srgbClr val="1D2433"/>
+                </a:solidFill>
+              </a:rPr>
+              <a:t>IKE_SA_INIT, IPv6, AH and rekey behaviour are tested on hand-built fixtures; strongSwan snippet not run (no Docker)</a:t>
+            </a:r>
+          </a:p>
+          <a:p>
+            <a:pPr>
+              <a:spcAft>
+                <a:spcPts val="900"/>
+              </a:spcAft>
+            </a:pPr>
+            <a:r>
+              <a:rPr b="1" sz="2100">
+                <a:solidFill>
+                  <a:srgbClr val="1D2433"/>
+                </a:solidFill>
+              </a:rPr>
+              <a:t>Replay, not live: </a:t>
+            </a:r>
+            <a:r>
+              <a:rPr sz="2100">
+                <a:solidFill>
+                  <a:srgbClr val="1D2433"/>
+                </a:solidFill>
+              </a:rPr>
+              <a:t>replay mode streams a capture file; live sniffing is not implemented</a:t>
+            </a:r>
+          </a:p>
+          <a:p>
+            <a:pPr>
+              <a:spcAft>
+                <a:spcPts val="900"/>
+              </a:spcAft>
+            </a:pPr>
+            <a:r>
+              <a:rPr b="1" sz="2100">
+                <a:solidFill>
+                  <a:srgbClr val="1D2433"/>
+                </a:solidFill>
+              </a:rPr>
+              <a:t>Next: </a:t>
+            </a:r>
+            <a:r>
+              <a:rPr sz="2100">
+                <a:solidFill>
+                  <a:srgbClr val="1D2433"/>
+                </a:solidFill>
+              </a:rPr>
+              <a:t>re-run the fixed testbed (real handshakes, real PFS labels, 30 s captures, repeats)</a:t>
+            </a:r>
+          </a:p>
+          <a:p>
+            <a:pPr>
+              <a:spcAft>
+                <a:spcPts val="900"/>
+              </a:spcAft>
+            </a:pPr>
+            <a:r>
+              <a:rPr b="1" sz="2100">
+                <a:solidFill>
+                  <a:srgbClr val="1D2433"/>
+                </a:solidFill>
+              </a:rPr>
+              <a:t>Next: </a:t>
+            </a:r>
+            <a:r>
+              <a:rPr sz="2100">
+                <a:solidFill>
+                  <a:srgbClr val="1D2433"/>
+                </a:solidFill>
+              </a:rPr>
+              <a:t>non-scripted traffic, IKEv1, authentication and rate limiting for a public deployment</a:t>
+            </a:r>
+          </a:p>
+        </p:txBody>
+      </p:sp>
+    </p:spTree>
+  </p:cSld>
+  <p:clrMapOvr>
+    <a:masterClrMapping/>
+  </p:clrMapOvr>
+</p:sld>
+</file>
+
+<file path=ppt/slides/slide2.xml><?xml version="1.0" encoding="utf-8"?>
+<p:sld xmlns:a="http://schemas.openxmlformats.org/drawingml/2006/main" xmlns:p="http://schemas.openxmlformats.org/presentationml/2006/main" xmlns:r="http://schemas.openxmlformats.org/officeDocument/2006/relationships">
+  <p:cSld>
+    <p:spTree>
+      <p:nvGrpSpPr>
+        <p:cNvPr id="1" name=""/>
+        <p:cNvGrpSpPr/>
+        <p:nvPr/>
+      </p:nvGrpSpPr>
+      <p:grpSpPr/>
+      <p:sp>
+        <p:nvSpPr>
+          <p:cNvPr id="2" name="Rectangle 1"/>
+          <p:cNvSpPr/>
+          <p:nvPr/>
+        </p:nvSpPr>
+        <p:spPr>
+          <a:xfrm>
+            <a:off x="0" y="0"/>
+            <a:ext cx="12191695" cy="1051560"/>
+          </a:xfrm>
+          <a:prstGeom prst="rect">
+            <a:avLst/>
+          </a:prstGeom>
+          <a:solidFill>
+            <a:srgbClr val="14203A"/>
+          </a:solidFill>
+          <a:ln>
+            <a:noFill/>
+          </a:ln>
+        </p:spPr>
+        <p:style>
+          <a:lnRef idx="1">
+            <a:schemeClr val="accent1"/>
+          </a:lnRef>
+          <a:fillRef idx="3">
+            <a:schemeClr val="accent1"/>
+          </a:fillRef>
+          <a:effectRef idx="2">
+            <a:schemeClr val="accent1"/>
+          </a:effectRef>
+          <a:fontRef idx="minor">
+            <a:schemeClr val="lt1"/>
+          </a:fontRef>
+        </p:style>
+        <p:txBody>
+          <a:bodyPr rtlCol="0" anchor="ctr"/>
+          <a:lstStyle/>
+          <a:p>
+            <a:pPr algn="ctr"/>
+          </a:p>
+        </p:txBody>
+      </p:sp>
+      <p:sp>
+        <p:nvSpPr>
+          <p:cNvPr id="3" name="TextBox 2"/>
+          <p:cNvSpPr txBox="1"/>
+          <p:nvPr/>
+        </p:nvSpPr>
+        <p:spPr>
+          <a:xfrm>
+            <a:off x="457200" y="164592"/>
+            <a:ext cx="11247120" cy="731520"/>
+          </a:xfrm>
+          <a:prstGeom prst="rect">
+            <a:avLst/>
+          </a:prstGeom>
+          <a:noFill/>
+        </p:spPr>
+        <p:txBody>
+          <a:bodyPr wrap="square">
+            <a:spAutoFit/>
+          </a:bodyPr>
+          <a:lstStyle/>
+          <a:p>
+            <a:pPr>
+              <a:defRPr sz="3000" b="1">
+                <a:solidFill>
+                  <a:srgbClr val="FFFFFF"/>
+                </a:solidFill>
+              </a:defRPr>
+            </a:pPr>
+            <a:r>
+              <a:t>The problem: encrypted does not mean understood</a:t>
             </a:r>
           </a:p>
         </p:txBody>
@@ -5411,7 +6265,7 @@
                   <a:srgbClr val="1D2433"/>
                 </a:solidFill>
               </a:rPr>
-              <a:t>Security score 0-100: </a:t>
+              <a:t>Is the VPN configured well?: </a:t>
             </a:r>
             <a:r>
               <a:rPr sz="2200">
@@ -5419,7 +6273,7 @@
                   <a:srgbClr val="1D2433"/>
                 </a:solidFill>
               </a:rPr>
-              <a:t>with LOW / MEDIUM / HIGH risk and a per-factor threat matrix</a:t>
+              <a:t>Cipher, key exchange group, forward secrecy, tunnel vs transport mode.</a:t>
             </a:r>
           </a:p>
           <a:p>
@@ -5434,7 +6288,7 @@
                   <a:srgbClr val="1D2433"/>
                 </a:solidFill>
               </a:rPr>
-              <a:t>Traffic classification: </a:t>
+              <a:t>What is inside the tunnel?: </a:t>
             </a:r>
             <a:r>
               <a:rPr sz="2200">
@@ -5442,7 +6296,7 @@
                   <a:srgbClr val="1D2433"/>
                 </a:solidFill>
               </a:rPr>
-              <a:t>Random Forest on 1-second windows of encrypted ESP packets</a:t>
+              <a:t>Web, video, voice, file transfer, ping - without decrypting.</a:t>
             </a:r>
           </a:p>
           <a:p>
@@ -5457,7 +6311,7 @@
                   <a:srgbClr val="1D2433"/>
                 </a:solidFill>
               </a:rPr>
-              <a:t>Explainability: </a:t>
+              <a:t>Hard part: </a:t>
             </a:r>
             <a:r>
               <a:rPr sz="2200">
@@ -5465,7 +6319,7 @@
                   <a:srgbClr val="1D2433"/>
                 </a:solidFill>
               </a:rPr>
-              <a:t>SHAP: which traffic features drove the decision; anomaly flags; time-window timeline</a:t>
+              <a:t>only the first IKE message (IKE_SA_INIT) is readable; everything after it is encrypted.</a:t>
             </a:r>
           </a:p>
           <a:p>
@@ -5480,7 +6334,7 @@
                   <a:srgbClr val="1D2433"/>
                 </a:solidFill>
               </a:rPr>
-              <a:t>Reports: </a:t>
+              <a:t>Our stance: </a:t>
             </a:r>
             <a:r>
               <a:rPr sz="2200">
@@ -5488,9 +6342,128 @@
                   <a:srgbClr val="1D2433"/>
                 </a:solidFill>
               </a:rPr>
-              <a:t>executive summary and technical report, HTML and PDF, generated on demand</a:t>
-            </a:r>
-          </a:p>
+              <a:t>never present a guess as a measurement - every value is tagged observed / declared / unknown.</a:t>
+            </a:r>
+          </a:p>
+        </p:txBody>
+      </p:sp>
+    </p:spTree>
+  </p:cSld>
+  <p:clrMapOvr>
+    <a:masterClrMapping/>
+  </p:clrMapOvr>
+</p:sld>
+</file>
+
+<file path=ppt/slides/slide3.xml><?xml version="1.0" encoding="utf-8"?>
+<p:sld xmlns:a="http://schemas.openxmlformats.org/drawingml/2006/main" xmlns:p="http://schemas.openxmlformats.org/presentationml/2006/main" xmlns:r="http://schemas.openxmlformats.org/officeDocument/2006/relationships">
+  <p:cSld>
+    <p:spTree>
+      <p:nvGrpSpPr>
+        <p:cNvPr id="1" name=""/>
+        <p:cNvGrpSpPr/>
+        <p:nvPr/>
+      </p:nvGrpSpPr>
+      <p:grpSpPr/>
+      <p:sp>
+        <p:nvSpPr>
+          <p:cNvPr id="2" name="Rectangle 1"/>
+          <p:cNvSpPr/>
+          <p:nvPr/>
+        </p:nvSpPr>
+        <p:spPr>
+          <a:xfrm>
+            <a:off x="0" y="0"/>
+            <a:ext cx="12191695" cy="1051560"/>
+          </a:xfrm>
+          <a:prstGeom prst="rect">
+            <a:avLst/>
+          </a:prstGeom>
+          <a:solidFill>
+            <a:srgbClr val="14203A"/>
+          </a:solidFill>
+          <a:ln>
+            <a:noFill/>
+          </a:ln>
+        </p:spPr>
+        <p:style>
+          <a:lnRef idx="1">
+            <a:schemeClr val="accent1"/>
+          </a:lnRef>
+          <a:fillRef idx="3">
+            <a:schemeClr val="accent1"/>
+          </a:fillRef>
+          <a:effectRef idx="2">
+            <a:schemeClr val="accent1"/>
+          </a:effectRef>
+          <a:fontRef idx="minor">
+            <a:schemeClr val="lt1"/>
+          </a:fontRef>
+        </p:style>
+        <p:txBody>
+          <a:bodyPr rtlCol="0" anchor="ctr"/>
+          <a:lstStyle/>
+          <a:p>
+            <a:pPr algn="ctr"/>
+          </a:p>
+        </p:txBody>
+      </p:sp>
+      <p:sp>
+        <p:nvSpPr>
+          <p:cNvPr id="3" name="TextBox 2"/>
+          <p:cNvSpPr txBox="1"/>
+          <p:nvPr/>
+        </p:nvSpPr>
+        <p:spPr>
+          <a:xfrm>
+            <a:off x="457200" y="164592"/>
+            <a:ext cx="11247120" cy="731520"/>
+          </a:xfrm>
+          <a:prstGeom prst="rect">
+            <a:avLst/>
+          </a:prstGeom>
+          <a:noFill/>
+        </p:spPr>
+        <p:txBody>
+          <a:bodyPr wrap="square">
+            <a:spAutoFit/>
+          </a:bodyPr>
+          <a:lstStyle/>
+          <a:p>
+            <a:pPr>
+              <a:defRPr sz="3000" b="1">
+                <a:solidFill>
+                  <a:srgbClr val="FFFFFF"/>
+                </a:solidFill>
+              </a:defRPr>
+            </a:pPr>
+            <a:r>
+              <a:t>What we built</a:t>
+            </a:r>
+          </a:p>
+        </p:txBody>
+      </p:sp>
+      <p:sp>
+        <p:nvSpPr>
+          <p:cNvPr id="4" name="TextBox 3"/>
+          <p:cNvSpPr txBox="1"/>
+          <p:nvPr/>
+        </p:nvSpPr>
+        <p:spPr>
+          <a:xfrm>
+            <a:off x="640080" y="1463040"/>
+            <a:ext cx="10972800" cy="4754880"/>
+          </a:xfrm>
+          <a:prstGeom prst="rect">
+            <a:avLst/>
+          </a:prstGeom>
+          <a:noFill/>
+        </p:spPr>
+        <p:txBody>
+          <a:bodyPr wrap="square">
+            <a:spAutoFit/>
+          </a:bodyPr>
+          <a:lstStyle/>
           <a:p>
             <a:pPr>
               <a:spcAft>
@@ -5498,20 +6471,135 @@
               </a:spcAft>
             </a:pPr>
             <a:r>
-              <a:rPr b="1" sz="2200">
+              <a:rPr b="1" sz="2000">
                 <a:solidFill>
                   <a:srgbClr val="1D2433"/>
                 </a:solidFill>
               </a:rPr>
-              <a:t>Plain-English mode: </a:t>
-            </a:r>
-            <a:r>
-              <a:rPr sz="2200">
+              <a:t>Security score 0-100: </a:t>
+            </a:r>
+            <a:r>
+              <a:rPr sz="2000">
                 <a:solidFill>
                   <a:srgbClr val="1D2433"/>
                 </a:solidFill>
               </a:rPr>
-              <a:t>every finding rewritten for non-experts</a:t>
+              <a:t>LOW / MEDIUM / HIGH, capped by assessment completeness so unknowns never read as 100 / LOW</a:t>
+            </a:r>
+          </a:p>
+          <a:p>
+            <a:pPr>
+              <a:spcAft>
+                <a:spcPts val="900"/>
+              </a:spcAft>
+            </a:pPr>
+            <a:r>
+              <a:rPr b="1" sz="2000">
+                <a:solidFill>
+                  <a:srgbClr val="1D2433"/>
+                </a:solidFill>
+              </a:rPr>
+              <a:t>Passive ESP fingerprint: </a:t>
+            </a:r>
+            <a:r>
+              <a:rPr sz="2000">
+                <a:solidFill>
+                  <a:srgbClr val="1D2433"/>
+                </a:solidFill>
+              </a:rPr>
+              <a:t>cipher family, integrity-tag candidates, tunnel vs transport, replay and rekey evidence - from sizes and sequence numbers only</a:t>
+            </a:r>
+          </a:p>
+          <a:p>
+            <a:pPr>
+              <a:spcAft>
+                <a:spcPts val="900"/>
+              </a:spcAft>
+            </a:pPr>
+            <a:r>
+              <a:rPr b="1" sz="2000">
+                <a:solidFill>
+                  <a:srgbClr val="1D2433"/>
+                </a:solidFill>
+              </a:rPr>
+              <a:t>Traffic classification: </a:t>
+            </a:r>
+            <a:r>
+              <a:rPr sz="2000">
+                <a:solidFill>
+                  <a:srgbClr val="1D2433"/>
+                </a:solidFill>
+              </a:rPr>
+              <a:t>Random Forest on 1-second windows, calibrated confidence, 'unrecognised' for unknown traffic</a:t>
+            </a:r>
+          </a:p>
+          <a:p>
+            <a:pPr>
+              <a:spcAft>
+                <a:spcPts val="900"/>
+              </a:spcAft>
+            </a:pPr>
+            <a:r>
+              <a:rPr b="1" sz="2000">
+                <a:solidFill>
+                  <a:srgbClr val="1D2433"/>
+                </a:solidFill>
+              </a:rPr>
+              <a:t>Recommendations: </a:t>
+            </a:r>
+            <a:r>
+              <a:rPr sz="2000">
+                <a:solidFill>
+                  <a:srgbClr val="1D2433"/>
+                </a:solidFill>
+              </a:rPr>
+              <a:t>prioritised fixes, a generated strongSwan snippet (unverified), before / after score</a:t>
+            </a:r>
+          </a:p>
+          <a:p>
+            <a:pPr>
+              <a:spcAft>
+                <a:spcPts val="900"/>
+              </a:spcAft>
+            </a:pPr>
+            <a:r>
+              <a:rPr b="1" sz="2000">
+                <a:solidFill>
+                  <a:srgbClr val="1D2433"/>
+                </a:solidFill>
+              </a:rPr>
+              <a:t>What-if + replay: </a:t>
+            </a:r>
+            <a:r>
+              <a:rPr sz="2000">
+                <a:solidFill>
+                  <a:srgbClr val="1D2433"/>
+                </a:solidFill>
+              </a:rPr>
+              <a:t>defence simulator; replay of a capture file (not live sniffing)</a:t>
+            </a:r>
+          </a:p>
+          <a:p>
+            <a:pPr>
+              <a:spcAft>
+                <a:spcPts val="900"/>
+              </a:spcAft>
+            </a:pPr>
+            <a:r>
+              <a:rPr b="1" sz="2000">
+                <a:solidFill>
+                  <a:srgbClr val="1D2433"/>
+                </a:solidFill>
+              </a:rPr>
+              <a:t>Reports: </a:t>
+            </a:r>
+            <a:r>
+              <a:rPr sz="2000">
+                <a:solidFill>
+                  <a:srgbClr val="1D2433"/>
+                </a:solidFill>
+              </a:rPr>
+              <a:t>executive summary and technical report, HTML and PDF; plain-English mode</a:t>
             </a:r>
           </a:p>
         </p:txBody>
@@ -6262,7 +7350,7 @@
                   <a:srgbClr val="1D2433"/>
                 </a:solidFill>
               </a:rPr>
-              <a:t>Score = weighted average of the rated factors; risk: &gt;= 80 LOW, &gt;= 50 MEDIUM, else HIGH</a:t>
+              <a:t>Base score = weighted average of the rated factors; risk: &gt;= 80 LOW, &gt;= 50 MEDIUM, else HIGH</a:t>
             </a:r>
           </a:p>
           <a:p>
@@ -6277,7 +7365,7 @@
                   <a:srgbClr val="1D2433"/>
                 </a:solidFill>
               </a:rPr>
-              <a:t>Mode (tunnel / transport) is shown but not scored; it is never assumed - it is encrypted</a:t>
+              <a:t>Assessment completeness: every finding is observed / inferred / declared / unknown; the final score is capped at 35 + 65 x completeness</a:t>
             </a:r>
           </a:p>
           <a:p>
@@ -6292,7 +7380,7 @@
                   <a:srgbClr val="1D2433"/>
                 </a:solidFill>
               </a:rPr>
-              <a:t>Real finding: none of our 216 captures contains a readable IKE_SA_INIT, so their settings are labelled 'declared by file name'</a:t>
+              <a:t>Real finding: none of our 216 captures contains a readable IKE_SA_INIT, so a real testbed file reads 64 / MEDIUM (44 % complete), not 100 / LOW</a:t>
             </a:r>
           </a:p>
         </p:txBody>
@@ -7373,35 +8461,417 @@
               </a:defRPr>
             </a:pPr>
             <a:r>
-              <a:t>The dashboard</a:t>
-            </a:r>
-          </a:p>
-        </p:txBody>
-      </p:sp>
-      <p:pic>
-        <p:nvPicPr>
-          <p:cNvPr id="4" name="Picture 3" descr="dashboard-top.png"/>
-          <p:cNvPicPr>
-            <a:picLocks noChangeAspect="1"/>
-          </p:cNvPicPr>
+              <a:t>New: passive ESP fingerprinting from sizes only</a:t>
+            </a:r>
+          </a:p>
+        </p:txBody>
+      </p:sp>
+      <p:graphicFrame>
+        <p:nvGraphicFramePr>
+          <p:cNvPr id="4" name="Table 3"/>
+          <p:cNvGraphicFramePr>
+            <a:graphicFrameLocks noGrp="1"/>
+          </p:cNvGraphicFramePr>
           <p:nvPr/>
-        </p:nvPicPr>
-        <p:blipFill>
-          <a:blip r:embed="rId3"/>
-          <a:stretch>
-            <a:fillRect/>
-          </a:stretch>
-        </p:blipFill>
+        </p:nvGraphicFramePr>
+        <p:xfrm>
+          <a:off x="457200" y="1371600"/>
+          <a:ext cx="6949440" cy="2304288"/>
+        </p:xfrm>
+        <a:graphic>
+          <a:graphicData uri="http://schemas.openxmlformats.org/drawingml/2006/table">
+            <a:tbl>
+              <a:tblPr firstRow="1" bandRow="1">
+                <a:tableStyleId>{5C22544A-7EE6-4342-B048-85BDC9FD1C3A}</a:tableStyleId>
+              </a:tblPr>
+              <a:tblGrid>
+                <a:gridCol w="4754880"/>
+                <a:gridCol w="2194560"/>
+              </a:tblGrid>
+              <a:tr h="384048">
+                <a:tc>
+                  <a:txBody>
+                    <a:bodyPr/>
+                    <a:lstStyle/>
+                    <a:p>
+                      <a:pPr>
+                        <a:defRPr sz="1400" b="1">
+                          <a:solidFill>
+                            <a:srgbClr val="FFFFFF"/>
+                          </a:solidFill>
+                        </a:defRPr>
+                      </a:pPr>
+                      <a:r>
+                        <a:t>Passive inference (grouped CV, 180 captures)</a:t>
+                      </a:r>
+                    </a:p>
+                  </a:txBody>
+                  <a:tcPr>
+                    <a:solidFill>
+                      <a:srgbClr val="2B7BB9"/>
+                    </a:solidFill>
+                  </a:tcPr>
+                </a:tc>
+                <a:tc>
+                  <a:txBody>
+                    <a:bodyPr/>
+                    <a:lstStyle/>
+                    <a:p>
+                      <a:pPr>
+                        <a:defRPr sz="1400" b="1">
+                          <a:solidFill>
+                            <a:srgbClr val="FFFFFF"/>
+                          </a:solidFill>
+                        </a:defRPr>
+                      </a:pPr>
+                      <a:r>
+                        <a:t>Result</a:t>
+                      </a:r>
+                    </a:p>
+                  </a:txBody>
+                  <a:tcPr>
+                    <a:solidFill>
+                      <a:srgbClr val="2B7BB9"/>
+                    </a:solidFill>
+                  </a:tcPr>
+                </a:tc>
+              </a:tr>
+              <a:tr h="384048">
+                <a:tc>
+                  <a:txBody>
+                    <a:bodyPr/>
+                    <a:lstStyle/>
+                    <a:p>
+                      <a:pPr>
+                        <a:defRPr sz="1400" b="0">
+                          <a:solidFill>
+                            <a:srgbClr val="1D2433"/>
+                          </a:solidFill>
+                        </a:defRPr>
+                      </a:pPr>
+                      <a:r>
+                        <a:t>Cipher family: answered / correct when answered</a:t>
+                      </a:r>
+                    </a:p>
+                  </a:txBody>
+                  <a:tcPr>
+                    <a:solidFill>
+                      <a:srgbClr val="EEF1F7"/>
+                    </a:solidFill>
+                  </a:tcPr>
+                </a:tc>
+                <a:tc>
+                  <a:txBody>
+                    <a:bodyPr/>
+                    <a:lstStyle/>
+                    <a:p>
+                      <a:pPr>
+                        <a:defRPr sz="1400" b="0">
+                          <a:solidFill>
+                            <a:srgbClr val="1D2433"/>
+                          </a:solidFill>
+                        </a:defRPr>
+                      </a:pPr>
+                      <a:r>
+                        <a:t>144 / 144  (100 %)</a:t>
+                      </a:r>
+                    </a:p>
+                  </a:txBody>
+                  <a:tcPr>
+                    <a:solidFill>
+                      <a:srgbClr val="EEF1F7"/>
+                    </a:solidFill>
+                  </a:tcPr>
+                </a:tc>
+              </a:tr>
+              <a:tr h="384048">
+                <a:tc>
+                  <a:txBody>
+                    <a:bodyPr/>
+                    <a:lstStyle/>
+                    <a:p>
+                      <a:pPr>
+                        <a:defRPr sz="1400" b="0">
+                          <a:solidFill>
+                            <a:srgbClr val="1D2433"/>
+                          </a:solidFill>
+                        </a:defRPr>
+                      </a:pPr>
+                      <a:r>
+                        <a:t>Cipher family: abstains (all ICMP, constant size)</a:t>
+                      </a:r>
+                    </a:p>
+                  </a:txBody>
+                  <a:tcPr>
+                    <a:solidFill>
+                      <a:srgbClr val="FFFFFF"/>
+                    </a:solidFill>
+                  </a:tcPr>
+                </a:tc>
+                <a:tc>
+                  <a:txBody>
+                    <a:bodyPr/>
+                    <a:lstStyle/>
+                    <a:p>
+                      <a:pPr>
+                        <a:defRPr sz="1400" b="0">
+                          <a:solidFill>
+                            <a:srgbClr val="1D2433"/>
+                          </a:solidFill>
+                        </a:defRPr>
+                      </a:pPr>
+                      <a:r>
+                        <a:t>36 captures</a:t>
+                      </a:r>
+                    </a:p>
+                  </a:txBody>
+                  <a:tcPr>
+                    <a:solidFill>
+                      <a:srgbClr val="FFFFFF"/>
+                    </a:solidFill>
+                  </a:tcPr>
+                </a:tc>
+              </a:tr>
+              <a:tr h="384048">
+                <a:tc>
+                  <a:txBody>
+                    <a:bodyPr/>
+                    <a:lstStyle/>
+                    <a:p>
+                      <a:pPr>
+                        <a:defRPr sz="1400" b="0">
+                          <a:solidFill>
+                            <a:srgbClr val="1D2433"/>
+                          </a:solidFill>
+                        </a:defRPr>
+                      </a:pPr>
+                      <a:r>
+                        <a:t>Tunnel vs transport: accuracy (all)</a:t>
+                      </a:r>
+                    </a:p>
+                  </a:txBody>
+                  <a:tcPr>
+                    <a:solidFill>
+                      <a:srgbClr val="EEF1F7"/>
+                    </a:solidFill>
+                  </a:tcPr>
+                </a:tc>
+                <a:tc>
+                  <a:txBody>
+                    <a:bodyPr/>
+                    <a:lstStyle/>
+                    <a:p>
+                      <a:pPr>
+                        <a:defRPr sz="1400" b="0">
+                          <a:solidFill>
+                            <a:srgbClr val="1D2433"/>
+                          </a:solidFill>
+                        </a:defRPr>
+                      </a:pPr>
+                      <a:r>
+                        <a:t>96.7 %</a:t>
+                      </a:r>
+                    </a:p>
+                  </a:txBody>
+                  <a:tcPr>
+                    <a:solidFill>
+                      <a:srgbClr val="EEF1F7"/>
+                    </a:solidFill>
+                  </a:tcPr>
+                </a:tc>
+              </a:tr>
+              <a:tr h="384048">
+                <a:tc>
+                  <a:txBody>
+                    <a:bodyPr/>
+                    <a:lstStyle/>
+                    <a:p>
+                      <a:pPr>
+                        <a:defRPr sz="1400" b="0">
+                          <a:solidFill>
+                            <a:srgbClr val="1D2433"/>
+                          </a:solidFill>
+                        </a:defRPr>
+                      </a:pPr>
+                      <a:r>
+                        <a:t>Tunnel vs transport: when it commits (coverage)</a:t>
+                      </a:r>
+                    </a:p>
+                  </a:txBody>
+                  <a:tcPr>
+                    <a:solidFill>
+                      <a:srgbClr val="FFFFFF"/>
+                    </a:solidFill>
+                  </a:tcPr>
+                </a:tc>
+                <a:tc>
+                  <a:txBody>
+                    <a:bodyPr/>
+                    <a:lstStyle/>
+                    <a:p>
+                      <a:pPr>
+                        <a:defRPr sz="1400" b="0">
+                          <a:solidFill>
+                            <a:srgbClr val="1D2433"/>
+                          </a:solidFill>
+                        </a:defRPr>
+                      </a:pPr>
+                      <a:r>
+                        <a:t>100 %  (89.4 %)</a:t>
+                      </a:r>
+                    </a:p>
+                  </a:txBody>
+                  <a:tcPr>
+                    <a:solidFill>
+                      <a:srgbClr val="FFFFFF"/>
+                    </a:solidFill>
+                  </a:tcPr>
+                </a:tc>
+              </a:tr>
+              <a:tr h="384048">
+                <a:tc>
+                  <a:txBody>
+                    <a:bodyPr/>
+                    <a:lstStyle/>
+                    <a:p>
+                      <a:pPr>
+                        <a:defRPr sz="1400" b="0">
+                          <a:solidFill>
+                            <a:srgbClr val="1D2433"/>
+                          </a:solidFill>
+                        </a:defRPr>
+                      </a:pPr>
+                      <a:r>
+                        <a:t>Shuffled-label control (chance 50 %)</a:t>
+                      </a:r>
+                    </a:p>
+                  </a:txBody>
+                  <a:tcPr>
+                    <a:solidFill>
+                      <a:srgbClr val="EEF1F7"/>
+                    </a:solidFill>
+                  </a:tcPr>
+                </a:tc>
+                <a:tc>
+                  <a:txBody>
+                    <a:bodyPr/>
+                    <a:lstStyle/>
+                    <a:p>
+                      <a:pPr>
+                        <a:defRPr sz="1400" b="0">
+                          <a:solidFill>
+                            <a:srgbClr val="1D2433"/>
+                          </a:solidFill>
+                        </a:defRPr>
+                      </a:pPr>
+                      <a:r>
+                        <a:t>45.4 %</a:t>
+                      </a:r>
+                    </a:p>
+                  </a:txBody>
+                  <a:tcPr>
+                    <a:solidFill>
+                      <a:srgbClr val="EEF1F7"/>
+                    </a:solidFill>
+                  </a:tcPr>
+                </a:tc>
+              </a:tr>
+            </a:tbl>
+          </a:graphicData>
+        </a:graphic>
+      </p:graphicFrame>
+      <p:sp>
+        <p:nvSpPr>
+          <p:cNvPr id="5" name="TextBox 4"/>
+          <p:cNvSpPr txBox="1"/>
+          <p:nvPr/>
+        </p:nvSpPr>
         <p:spPr>
           <a:xfrm>
-            <a:off x="2704513" y="1188720"/>
-            <a:ext cx="6752492" cy="5486400"/>
+            <a:off x="7589520" y="1371600"/>
+            <a:ext cx="4297680" cy="4114800"/>
           </a:xfrm>
           <a:prstGeom prst="rect">
             <a:avLst/>
           </a:prstGeom>
+          <a:noFill/>
         </p:spPr>
-      </p:pic>
+        <p:txBody>
+          <a:bodyPr wrap="square">
+            <a:spAutoFit/>
+          </a:bodyPr>
+          <a:lstStyle/>
+          <a:p>
+            <a:pPr>
+              <a:spcAft>
+                <a:spcPts val="900"/>
+              </a:spcAft>
+            </a:pPr>
+            <a:r>
+              <a:rPr b="1" sz="1600">
+                <a:solidFill>
+                  <a:srgbClr val="1D2433"/>
+                </a:solidFill>
+              </a:rPr>
+              <a:t>Also: </a:t>
+            </a:r>
+            <a:r>
+              <a:rPr sz="1600">
+                <a:solidFill>
+                  <a:srgbClr val="1D2433"/>
+                </a:solidFill>
+              </a:rPr>
+              <a:t>SPI / sequence analysis: replay evidence, gaps, duplicates, reordering, rekeys</a:t>
+            </a:r>
+          </a:p>
+          <a:p>
+            <a:pPr>
+              <a:spcAft>
+                <a:spcPts val="900"/>
+              </a:spcAft>
+            </a:pPr>
+            <a:r>
+              <a:rPr b="1" sz="1600">
+                <a:solidFill>
+                  <a:srgbClr val="1D2433"/>
+                </a:solidFill>
+              </a:rPr>
+              <a:t>Not observable: </a:t>
+            </a:r>
+            <a:r>
+              <a:rPr sz="1600">
+                <a:solidFill>
+                  <a:srgbClr val="1D2433"/>
+                </a:solidFill>
+              </a:rPr>
+              <a:t>AES-128 vs 256, PFS, auth method, SA lifetime without a rekey: reported unknown</a:t>
+            </a:r>
+          </a:p>
+          <a:p>
+            <a:pPr>
+              <a:spcAft>
+                <a:spcPts val="900"/>
+              </a:spcAft>
+            </a:pPr>
+            <a:r>
+              <a:rPr b="1" sz="1600">
+                <a:solidFill>
+                  <a:srgbClr val="1D2433"/>
+                </a:solidFill>
+              </a:rPr>
+              <a:t>Lab data: </a:t>
+            </a:r>
+            <a:r>
+              <a:rPr sz="1600">
+                <a:solidFill>
+                  <a:srgbClr val="1D2433"/>
+                </a:solidFill>
+              </a:rPr>
+              <a:t>scripted traffic, one strongSwan version</a:t>
+            </a:r>
+          </a:p>
+        </p:txBody>
+      </p:sp>
     </p:spTree>
   </p:cSld>
   <p:clrMapOvr>

</xml_diff>